<commit_message>
Progress slides: speaker notes with training/data details for Q&A (slides 1-3)
Co-Authored-By: Claude Opus 5.5 (1M context) <noreply@anthropic.com>
</commit_message>
<xml_diff>
--- a/results/progress_slides_2026-10-22.pptx
+++ b/results/progress_slides_2026-10-22.pptx
@@ -985,7 +985,24 @@
               <a:t>【台本】（約50秒）
 喉マイクは首の振動を拾うので騒音に強いのですが、TAPS では 8 kHz で収録されていて、4 kHz 以上の成分が最初からありません。そのまま Whisper に入れると誤り率は 0.45 です。
 そこで、NVIDIA が公開している事前学習済みの生成モデルを、喉マイクから気導マイクへの対で追加学習し、欠けた成分を補います。さらに、Whisper の損失で学習した音声強調の出力と、振幅を半分ずつ混ぜます。これを融合Aと呼んでいます。混ぜるだけなので新しい学習はいりません。
-評価は9種の認識器で行い、損失と設定の選択には Whisper-small だけを使っています。</a:t>
+評価は9種の認識器で行い、損失と設定の選択には Whisper-small だけを使っています。
+【質問されたら：データ】
+・TAPS（Kim et al., Scientific Data 2026）：韓国語の読み上げ（ニュース文・日常文）。喉マイク（加速度センサ、8 kHz 収録→16 kHz 配布）と気導マイクの同時収録。train 40話者・4,000発話（約10.2時間）、dev 10話者・1,000発話、test 10話者・1,000発話（約2.6時間）。各話者100発話、平均約9秒。話者は分割間で重ならない（test は声の高さで見て低い声5人・高い声5人）
+・test の文で train と完全に一致するのは5種類だけ
+【質問されたら：生成モデル】
+・NVIDIA NeMo の sr_ssl_flowmatching_16k_430m（Ku et al., arXiv:2409.16117）。複素 STFT 上の flow matching、4.3億パラメータ。大規模音声で、マスクした区間を復元するタスクで事前学習済み
+・追加学習：入力（条件）＝喉マイク、目標＝同じ発話の気導マイク。TAPS train 4,000対、20k step、batch 8、6.14秒のランダム切り出し、学習率 1e-4、EMA、32ビット浮動小数点。ASR の損失は使っていない
+・重みは学習終了時（最終ステップ）のものを使用。途中の検証は dev の100発話で PESQ を見ていただけで、重みの選択には使っていない
+・推論：標準正規分布の雑音から出発し、喉マイクを条件に ODE を Euler 法20ステップで解く。乱数を変えて4回生成し、STFT 振幅を平均（位相は1つ目）。4回平均で 0.180→0.169（Whisper-small）
+・学習時間：RTX PRO 6000 で 20k step 約3.5時間
+・同じ構造を乱数初期値から同じ量だけ学習すると 0.551 と大きく悪化 → 効いているのは事前学習（ただし学習量不足の可能性もある）
+【質問されたら：Whisper 用の強調（CE-SE）】
+・TAPS 公開の SE-Conformer（Kim &amp; Seo, Interspeech 2021。1210万パラメータ）を初期値に追加学習
+・損失＝L1 波形損失＋多重解像度 STFT 損失（気導音に対して）＋ λ × Whisper-small の交差エントロピー（正解テキスト、教師強制、言語は韓国語）。Whisper は凍結し、強調器だけを更新。対数メルは Whisper と同じ計算を微分できる形で実装
+・λ は dev の CER で {0, 0.1, 0.5, 1, 2, 5, 10} から選んで 10。Adam、学習率 3e-4、batch 4、最大50エポック、dev の損失で early stopping。15秒を超える発話は学習から除外
+【質問されたら：融合】
+・STFT（512点、シフト128点）の振幅を (1−w)|G| + w|C| で平均し、位相は生成モデル。w は dev で Whisper-small だけを見て {0.25, 0.5, 0.75} から選び 0.5（CER 0.202 / 0.196 / 0.198）
+・なぜ振幅だけ：位相の違う2つの波形をそのまま足すと打ち消し合う</a:t>
             </a:r>
             <a:endParaRPr lang="en-US" dirty="0"/>
           </a:p>
@@ -1077,7 +1094,20 @@
 主な結果です。左から、処理なし、TAPS が公開している従来の音声強調、生成モデル、融合Aです。
 生成モデルは、系統の違う認識器も含めた9種すべてで、従来の強調より誤りを 19〜32% 減らしました。
 特に見てほしいのは太字の行で、喉マイクの音で追加学習した Whisper です。以前の実験では、この Whisper に音声強調を足すと逆に悪くなっていましたが、生成モデルなら 0.138 から 0.092 まで下がりました。認識器を学習し直した後でも、前処理で上乗せできます。
-融合A は Whisper 系にさらに 2〜8% 効きますが、作りの違う Zipformer では悪化します。融合の上乗せは、学習を3回やり直しても再現しました。</a:t>
+融合A は Whisper 系にさらに 2〜8% 効きますが、作りの違う Zipformer では悪化します。融合の上乗せは、学習を3回やり直しても再現しました。
+【質問されたら：認識器】
+・Whisper（small / base / medium / large-v3-turbo）：faster-whisper（CTranslate2）、言語を韓国語に指定
+・FT Whisper：Whisper-small を TAPS の喉マイク train で追加学習（学習率 1e-5、batch 16、dev で early stopping）。気導マイクは使っていない
+・Qwen3-ASR-1.7B：エンコーダは Whisper と別だが、入力は同じ形式の対数メル（128次元）
+・系統が違う認識器：XLSR（kresnik/wav2vec2-large-xlsr-korean。XLSR-53 を Zeroth Korean で追加学習した波形入力の CTC）、MMS-1B（韓国語アダプタ）、Zipformer（sherpa-onnx、KsponSpeech のみで学習、Kaldi 型 fbank 入力）
+・損失と設定の選択に使ったのは Whisper-small だけ。他の8種は評価専用
+【質問されたら：評価】
+・CER は正解と認識結果の両方から句読点を除き、発話ごとに 1.0 で打ち切って平均（上限付き発話平均 CER）。総編集距離÷総文字数の通常の CER でも主な傾向は同じ
+・検定：同じ話者の発話は独立でないので、話者ごとの平均 CER（10人）で両側 Wilcoxon。条件の対ごとに認識器をまたいで Holm 補正。10人全員が同じ向きのとき未補正 p≈0.002、補正後 p≈0.018
+・再現性：CE-SE と生成モデルを2回ずつ学習し直し、生成×4 はほぼ同じ（多くの認識器で差 0.001 程度）、融合の上乗せは small・medium・turbo・FT で3回とも有意
+・注意：融合を採用したことや内挿への変更は test の他の認識器も見て決めたので、TAPS 上の分析は探索的と論文に明記している
+【質問されたら：処理なしの FT Whisper が TAPS SE より良いのはなぜ】
+・FT Whisper は喉マイクの生音声で学習しているので、生音声が得意（0.138）。従来の強調を通すと学習時と違う音になり悪化（0.146）。生成モデルの出力では、学習時と違う音なのに良くなった（0.100）</a:t>
             </a:r>
             <a:endParaRPr lang="en-US" dirty="0"/>
           </a:p>
@@ -1168,7 +1198,23 @@
               <a:t>【台本】（約45秒）
 評価が TAPS の中で閉じているので、別のデータセットでも確かめました。フランス語の VibraVox です。
 TAPS で作った部品をそのまま使うと、どの処理も処理なしより悪くなりました。音量や帯域をそろえても変わらなかったので、機器の違いが効いていると考えています。
-一方、VibraVox の対データで同じ手順の適応をやり直すと、生成モデルで誤りが 70〜82% 減り、融合A でさらに減りました。手法の作り方はデータセットを越えて成り立ちますが、部品は機器ごとに適応が必要です。ただ、1,000 対、1.3 時間ほどのデータで、全データの改善量の 86% が得られています。</a:t>
+一方、VibraVox の対データで同じ手順の適応をやり直すと、生成モデルで誤りが 70〜82% 減り、融合A でさらに減りました。手法の作り方はデータセットを越えて成り立ちますが、部品は機器ごとに適応が必要です。ただ、1,000 対、1.3 時間ほどのデータで、全データの改善量の 86% が得られています。
+【質問されたら：VibraVox のデータ】
+・VibraVox（Hauret et al., Speech Communication 2025）の speech_clean：仏語の読み上げ、体内伝導センサー5種＋ヘッドセット（気導）の同時収録。今回は喉マイクとヘッドセットの対を使用
+・train 20,981対（約26.3時間、149話者）、dev（validation）2,523発話、test 3,064発話・21話者。話者は分割間で重ならない。test の文で train と完全に一致するのは1文だけ
+・CER は句読点除去に加えて小文字化
+【質問されたら：適応のやり方】
+・生成モデル：同じ NVIDIA の事前学習済みモデルから、VibraVox train で 20k step 追加学習（TAPS と同じ設定）
+・強調：TAPS SE を VibraVox で再構成損失だけで追加学習（VibraVox SE）→ それを初期値に、仏語の Whisper-small の CE（λ=10）で学習
+・λ=10、w=0.5、N=4 は TAPS で決めた値に固定。内挿の α だけ VibraVox の dev で選び直した（TAPS と同じ 0.7）
+・系統が違う認識器：XLSR 仏語版（jonatasgrosman/wav2vec2-large-xlsr-53-french、言語モデルなしの貪欲復号）、MMS-1B（仏語アダプタ）
+【質問されたら：そのまま使うと悪化した理由】
+・音量を TAPS にそろえ、4 kHz で帯域制限した入力でも結果はほぼ同じ → 単純な音量・帯域の違いではない
+・言語の違いか機器の違いかは、まだ切り分けていない。同じ VibraVox の別センサー（耳栓型・額）に喉マイク用の部品を使っても悪化したので、言語が同じでも機器が変われば失敗しうる
+【質問されたら：少ない対データ】
+・train から無作為に選んだ一部の対で、生成モデルだけを 10k step 適応（全データは 20k step なので学習量も違う）。乱数は1通りで各1試行
+・Whisper-small：200対（約15分）0.272、1,000対（約1.3時間）0.148、5,000対（約6.3時間）0.131、全データ 0.102（処理なし 0.422）
+・今後：乱数を変えた繰り返し、少ない話者で集めた場合、学習量の調整</a:t>
             </a:r>
             <a:endParaRPr lang="en-US" dirty="0"/>
           </a:p>

</xml_diff>